<commit_message>
Results R2: darker zeros to pass the 4.5:1 contrast check
Co-Authored-By: Claude Opus 5.5 <noreply@anthropic.com>
Claude-Session: https://claude.ai/code/session_01KcycczqUBG98FnzsgJYAW8
</commit_message>
<xml_diff>
--- a/presentation/RIGOR_results_R1_R4.pptx
+++ b/presentation/RIGOR_results_R1_R4.pptx
@@ -5063,7 +5063,7 @@
             <a:r>
               <a:rPr lang="en-US" sz="1450" b="0" i="0" dirty="0">
                 <a:solidFill>
-                  <a:srgbClr val="9AA3A9"/>
+                  <a:srgbClr val="6B747B"/>
                 </a:solidFill>
                 <a:latin typeface="Calibri"/>
                 <a:cs typeface="Calibri"/>
@@ -5102,7 +5102,7 @@
             <a:r>
               <a:rPr lang="en-US" sz="1450" b="0" i="0" dirty="0">
                 <a:solidFill>
-                  <a:srgbClr val="9AA3A9"/>
+                  <a:srgbClr val="6B747B"/>
                 </a:solidFill>
                 <a:latin typeface="Calibri"/>
                 <a:cs typeface="Calibri"/>
@@ -5141,7 +5141,7 @@
             <a:r>
               <a:rPr lang="en-US" sz="1450" b="0" i="0" dirty="0">
                 <a:solidFill>
-                  <a:srgbClr val="9AA3A9"/>
+                  <a:srgbClr val="6B747B"/>
                 </a:solidFill>
                 <a:latin typeface="Calibri"/>
                 <a:cs typeface="Calibri"/>
@@ -5219,7 +5219,7 @@
             <a:r>
               <a:rPr lang="en-US" sz="1450" b="0" i="0" dirty="0">
                 <a:solidFill>
-                  <a:srgbClr val="9AA3A9"/>
+                  <a:srgbClr val="6B747B"/>
                 </a:solidFill>
                 <a:latin typeface="Calibri"/>
                 <a:cs typeface="Calibri"/>
@@ -5258,7 +5258,7 @@
             <a:r>
               <a:rPr lang="en-US" sz="1450" b="0" i="0" dirty="0">
                 <a:solidFill>
-                  <a:srgbClr val="9AA3A9"/>
+                  <a:srgbClr val="6B747B"/>
                 </a:solidFill>
                 <a:latin typeface="Calibri"/>
                 <a:cs typeface="Calibri"/>
@@ -5297,7 +5297,7 @@
             <a:r>
               <a:rPr lang="en-US" sz="1450" b="0" i="0" dirty="0">
                 <a:solidFill>
-                  <a:srgbClr val="9AA3A9"/>
+                  <a:srgbClr val="6B747B"/>
                 </a:solidFill>
                 <a:latin typeface="Calibri"/>
                 <a:cs typeface="Calibri"/>
@@ -5414,7 +5414,7 @@
             <a:r>
               <a:rPr lang="en-US" sz="1450" b="0" i="0" dirty="0">
                 <a:solidFill>
-                  <a:srgbClr val="9AA3A9"/>
+                  <a:srgbClr val="6B747B"/>
                 </a:solidFill>
                 <a:latin typeface="Calibri"/>
                 <a:cs typeface="Calibri"/>
@@ -5453,7 +5453,7 @@
             <a:r>
               <a:rPr lang="en-US" sz="1450" b="0" i="0" dirty="0">
                 <a:solidFill>
-                  <a:srgbClr val="9AA3A9"/>
+                  <a:srgbClr val="6B747B"/>
                 </a:solidFill>
                 <a:latin typeface="Calibri"/>
                 <a:cs typeface="Calibri"/>

</xml_diff>